<commit_message>
docs(slides): onda 2 + screenshots de UI
Sabado: 3 slides novos (estrutura src/, promover @champion, /predict+WineInput) e 3 screenshots de UI (compare, registry @champion, swagger).
Domingo: 3 screenshots de UI (CI Actions verde, docker compose, drift Evidently).
</commit_message>
<xml_diff>
--- a/Slides_Domingo.pptx
+++ b/Slides_Domingo.pptx
@@ -15,6 +15,7 @@
     <p:sldId id="260" r:id="rId6"/>
     <p:sldId id="261" r:id="rId7"/>
     <p:sldId id="262" r:id="rId8"/>
+    <p:sldId id="295" r:id="rId51"/>
     <p:sldId id="263" r:id="rId9"/>
     <p:sldId id="264" r:id="rId10"/>
     <p:sldId id="265" r:id="rId11"/>
@@ -22,6 +23,7 @@
     <p:sldId id="267" r:id="rId13"/>
     <p:sldId id="268" r:id="rId14"/>
     <p:sldId id="269" r:id="rId15"/>
+    <p:sldId id="294" r:id="rId50"/>
     <p:sldId id="270" r:id="rId16"/>
     <p:sldId id="271" r:id="rId17"/>
     <p:sldId id="272" r:id="rId18"/>
@@ -29,6 +31,7 @@
     <p:sldId id="274" r:id="rId20"/>
     <p:sldId id="275" r:id="rId21"/>
     <p:sldId id="276" r:id="rId22"/>
+    <p:sldId id="293" r:id="rId49"/>
     <p:sldId id="277" r:id="rId23"/>
     <p:sldId id="278" r:id="rId24"/>
     <p:sldId id="279" r:id="rId25"/>
@@ -14601,6 +14604,132 @@
 </p:sld>
 </file>
 
+<file path=ppt/slides/slide38.xml><?xml version="1.0" encoding="utf-8"?>
+<p:sld xmlns:a="http://schemas.openxmlformats.org/drawingml/2006/main" xmlns:p="http://schemas.openxmlformats.org/presentationml/2006/main" xmlns:r="http://schemas.openxmlformats.org/officeDocument/2006/relationships">
+  <p:cSld>
+    <p:spTree>
+      <p:nvGrpSpPr>
+        <p:cNvPr id="1" name=""/>
+        <p:cNvGrpSpPr/>
+        <p:nvPr/>
+      </p:nvGrpSpPr>
+      <p:grpSpPr/>
+      <p:sp>
+        <p:nvSpPr>
+          <p:cNvPr id="2" name="Title 1"/>
+          <p:cNvSpPr>
+            <a:spLocks noGrp="1"/>
+          </p:cNvSpPr>
+          <p:nvPr>
+            <p:ph type="title"/>
+          </p:nvPr>
+        </p:nvSpPr>
+        <p:spPr/>
+        <p:txBody>
+          <a:bodyPr/>
+          <a:lstStyle/>
+          <a:p>
+            <a:r>
+              <a:t>Evidently: relatorio de drift (UI)</a:t>
+            </a:r>
+          </a:p>
+        </p:txBody>
+      </p:sp>
+      <p:pic>
+        <p:nvPicPr>
+          <p:cNvPr id="3" name="Picture 2" descr="drift_report.png"/>
+          <p:cNvPicPr>
+            <a:picLocks noChangeAspect="1"/>
+          </p:cNvPicPr>
+          <p:nvPr/>
+        </p:nvPicPr>
+        <p:blipFill>
+          <a:blip r:embed="rId2"/>
+          <a:stretch>
+            <a:fillRect/>
+          </a:stretch>
+        </p:blipFill>
+        <p:spPr>
+          <a:xfrm>
+            <a:off x="1609200" y="1300000"/>
+            <a:ext cx="5925600" cy="3703500"/>
+          </a:xfrm>
+          <a:prstGeom prst="rect">
+            <a:avLst/>
+          </a:prstGeom>
+        </p:spPr>
+      </p:pic>
+    </p:spTree>
+  </p:cSld>
+  <p:clrMapOvr>
+    <a:masterClrMapping/>
+  </p:clrMapOvr>
+</p:sld>
+</file>
+
+<file path=ppt/slides/slide39.xml><?xml version="1.0" encoding="utf-8"?>
+<p:sld xmlns:a="http://schemas.openxmlformats.org/drawingml/2006/main" xmlns:p="http://schemas.openxmlformats.org/presentationml/2006/main" xmlns:r="http://schemas.openxmlformats.org/officeDocument/2006/relationships">
+  <p:cSld>
+    <p:spTree>
+      <p:nvGrpSpPr>
+        <p:cNvPr id="1" name=""/>
+        <p:cNvGrpSpPr/>
+        <p:nvPr/>
+      </p:nvGrpSpPr>
+      <p:grpSpPr/>
+      <p:sp>
+        <p:nvSpPr>
+          <p:cNvPr id="2" name="Title 1"/>
+          <p:cNvSpPr>
+            <a:spLocks noGrp="1"/>
+          </p:cNvSpPr>
+          <p:nvPr>
+            <p:ph type="title"/>
+          </p:nvPr>
+        </p:nvSpPr>
+        <p:spPr/>
+        <p:txBody>
+          <a:bodyPr/>
+          <a:lstStyle/>
+          <a:p>
+            <a:r>
+              <a:t>Deploy local: docker compose (UI)</a:t>
+            </a:r>
+          </a:p>
+        </p:txBody>
+      </p:sp>
+      <p:pic>
+        <p:nvPicPr>
+          <p:cNvPr id="3" name="Picture 2" descr="compose_up.png"/>
+          <p:cNvPicPr>
+            <a:picLocks noChangeAspect="1"/>
+          </p:cNvPicPr>
+          <p:nvPr/>
+        </p:nvPicPr>
+        <p:blipFill>
+          <a:blip r:embed="rId2"/>
+          <a:stretch>
+            <a:fillRect/>
+          </a:stretch>
+        </p:blipFill>
+        <p:spPr>
+          <a:xfrm>
+            <a:off x="640000" y="1300000"/>
+            <a:ext cx="7864000" cy="3686250"/>
+          </a:xfrm>
+          <a:prstGeom prst="rect">
+            <a:avLst/>
+          </a:prstGeom>
+        </p:spPr>
+      </p:pic>
+    </p:spTree>
+  </p:cSld>
+  <p:clrMapOvr>
+    <a:masterClrMapping/>
+  </p:clrMapOvr>
+</p:sld>
+</file>
+
 <file path=ppt/slides/slide4.xml><?xml version="1.0" encoding="utf-8"?>
 <p:sld xmlns:a="http://schemas.openxmlformats.org/drawingml/2006/main" xmlns:r="http://schemas.openxmlformats.org/officeDocument/2006/relationships" xmlns:p="http://schemas.openxmlformats.org/presentationml/2006/main">
   <p:cSld>
@@ -14688,6 +14817,69 @@
           </a:p>
         </p:txBody>
       </p:sp>
+    </p:spTree>
+  </p:cSld>
+  <p:clrMapOvr>
+    <a:masterClrMapping/>
+  </p:clrMapOvr>
+</p:sld>
+</file>
+
+<file path=ppt/slides/slide40.xml><?xml version="1.0" encoding="utf-8"?>
+<p:sld xmlns:a="http://schemas.openxmlformats.org/drawingml/2006/main" xmlns:p="http://schemas.openxmlformats.org/presentationml/2006/main" xmlns:r="http://schemas.openxmlformats.org/officeDocument/2006/relationships">
+  <p:cSld>
+    <p:spTree>
+      <p:nvGrpSpPr>
+        <p:cNvPr id="1" name=""/>
+        <p:cNvGrpSpPr/>
+        <p:nvPr/>
+      </p:nvGrpSpPr>
+      <p:grpSpPr/>
+      <p:sp>
+        <p:nvSpPr>
+          <p:cNvPr id="2" name="Title 1"/>
+          <p:cNvSpPr>
+            <a:spLocks noGrp="1"/>
+          </p:cNvSpPr>
+          <p:nvPr>
+            <p:ph type="title"/>
+          </p:nvPr>
+        </p:nvSpPr>
+        <p:spPr/>
+        <p:txBody>
+          <a:bodyPr/>
+          <a:lstStyle/>
+          <a:p>
+            <a:r>
+              <a:t>CI verde no GitHub Actions (UI)</a:t>
+            </a:r>
+          </a:p>
+        </p:txBody>
+      </p:sp>
+      <p:pic>
+        <p:nvPicPr>
+          <p:cNvPr id="3" name="Picture 2" descr="ci_actions.png"/>
+          <p:cNvPicPr>
+            <a:picLocks noChangeAspect="1"/>
+          </p:cNvPicPr>
+          <p:nvPr/>
+        </p:nvPicPr>
+        <p:blipFill>
+          <a:blip r:embed="rId2"/>
+          <a:stretch>
+            <a:fillRect/>
+          </a:stretch>
+        </p:blipFill>
+        <p:spPr>
+          <a:xfrm>
+            <a:off x="1905480" y="1300000"/>
+            <a:ext cx="5333040" cy="3703500"/>
+          </a:xfrm>
+          <a:prstGeom prst="rect">
+            <a:avLst/>
+          </a:prstGeom>
+        </p:spPr>
+      </p:pic>
     </p:spTree>
   </p:cSld>
   <p:clrMapOvr>

</xml_diff>